<commit_message>
fix: aplica melhorias da auditoria final
</commit_message>
<xml_diff>
--- a/ENTREGAVEIS/Seminario_React_2ADS.pptx
+++ b/ENTREGAVEIS/Seminario_React_2ADS.pptx
@@ -4,6 +4,9 @@
   <p:sldMasterIdLst>
     <p:sldMasterId id="2147483648" r:id="rId1"/>
   </p:sldMasterIdLst>
+  <p:notesMasterIdLst>
+    <p:notesMasterId r:id="rId17"/>
+  </p:notesMasterIdLst>
   <p:sldIdLst>
     <p:sldId id="256" r:id="rId2"/>
     <p:sldId id="257" r:id="rId3"/>
@@ -21,9 +24,6 @@
     <p:sldId id="269" r:id="rId15"/>
     <p:sldId id="270" r:id="rId16"/>
   </p:sldIdLst>
-  <p:notesMasterIdLst>
-    <p:notesMasterId r:id="rId17"/>
-  </p:notesMasterIdLst>
   <p:sldSz cx="12191695" cy="6858000"/>
   <p:notesSz cx="6858000" cy="12191695"/>
   <p:defaultTextStyle>
@@ -4843,7 +4843,7 @@
                   </a:extLst>
                 </a:hlinkClick>
               </a:rPr>
-              <a:t>https://engineering.fb.com/2025/10/07/open-source/introducing-the-react-foundation-the-new-home-for-react-react-native/</a:t>
+              <a:t>Fonte: Meta Engineering — Introducing the React Foundation</a:t>
             </a:r>
             <a:endParaRPr lang="en-US" sz="740" dirty="0"/>
           </a:p>
@@ -5367,7 +5367,7 @@
                   <a:srgbClr val="10798E"/>
                 </a:solidFill>
               </a:rPr>
-              <a:t>CORREÇÃO</a:t>
+              <a:t>PATCH INICIAL</a:t>
             </a:r>
             <a:endParaRPr lang="en-US" sz="900" dirty="0"/>
           </a:p>
@@ -5405,7 +5405,7 @@
                   <a:srgbClr val="111719"/>
                 </a:solidFill>
               </a:rPr>
-              <a:t>19.0.1 · 19.1.2 · 19.2.1</a:t>
+              <a:t>19.0.1 · 19.1.2 · 19.2.1; usar a versão atual suportada</a:t>
             </a:r>
             <a:endParaRPr lang="en-US" sz="1230" dirty="0"/>
           </a:p>
@@ -5573,7 +5573,7 @@
                   </a:extLst>
                 </a:hlinkClick>
               </a:rPr>
-              <a:t>https://react.dev/blog/2025/12/03/critical-security-vulnerability-in-react-server-components</a:t>
+              <a:t>Fonte: React Security — CVE-2025-55182</a:t>
             </a:r>
             <a:endParaRPr lang="en-US" sz="740" dirty="0"/>
           </a:p>
@@ -5775,7 +5775,7 @@
       </p:sp>
       <p:pic>
         <p:nvPicPr>
-          <p:cNvPr id="5" name="Image 0" descr="Tela real da demonstração ReactLab">    </p:cNvPr>
+          <p:cNvPr id="5" name="Image 0" descr="Tela real da demonstração ReactLab"/>
           <p:cNvPicPr>
             <a:picLocks noChangeAspect="1"/>
           </p:cNvPicPr>
@@ -7667,7 +7667,7 @@
                   </a:extLst>
                 </a:hlinkClick>
               </a:rPr>
-              <a:t>react.dev/blog/.../CVE-2025-55182</a:t>
+              <a:t>React — CVE-2025-55182</a:t>
             </a:r>
             <a:endParaRPr lang="en-US" sz="970" dirty="0"/>
           </a:p>
@@ -8453,7 +8453,7 @@
                   </a:extLst>
                 </a:hlinkClick>
               </a:rPr>
-              <a:t>https://react.dev/learn</a:t>
+              <a:t>Fonte: React Docs — Quick Start</a:t>
             </a:r>
             <a:endParaRPr lang="en-US" sz="740" dirty="0"/>
           </a:p>
@@ -8769,7 +8769,7 @@
                   <a:srgbClr val="9EACAF"/>
                 </a:solidFill>
               </a:rPr>
-              <a:t>Código aberto</a:t>
+              <a:t>Jordan Walke · Facebook</a:t>
             </a:r>
             <a:endParaRPr lang="en-US" sz="1050" dirty="0"/>
           </a:p>
@@ -9264,7 +9264,7 @@
                   <a:srgbClr val="9EACAF"/>
                 </a:solidFill>
               </a:rPr>
-              <a:t>Foundation + 19.3</a:t>
+              <a:t>Foundation 19.3</a:t>
             </a:r>
             <a:endParaRPr lang="en-US" sz="1050" dirty="0"/>
           </a:p>
@@ -9312,7 +9312,7 @@
                   </a:extLst>
                 </a:hlinkClick>
               </a:rPr>
-              <a:t>https://react.dev/versions · https://react.dev/blog/2026/02/24/the-react-foundation · https://react.dev/blog/2026/09/09/react-19-3</a:t>
+              <a:t>Fontes: React Versions · React Foundation · React 19.3</a:t>
             </a:r>
             <a:endParaRPr lang="en-US" sz="740" dirty="0"/>
           </a:p>
@@ -9841,7 +9841,7 @@
                   </a:extLst>
                 </a:hlinkClick>
               </a:rPr>
-              <a:t>https://react.dev/learn/creating-a-react-app</a:t>
+              <a:t>Fonte: React Docs — Creating a React App</a:t>
             </a:r>
             <a:endParaRPr lang="en-US" sz="740" dirty="0"/>
           </a:p>
@@ -10854,7 +10854,7 @@
                   </a:extLst>
                 </a:hlinkClick>
               </a:rPr>
-              <a:t>https://react.dev/learn · https://react.dev/learn/render-and-commit</a:t>
+              <a:t>Fontes: React Docs — Learn · Render and Commit</a:t>
             </a:r>
             <a:endParaRPr lang="en-US" sz="740" dirty="0"/>
           </a:p>
@@ -11684,7 +11684,7 @@
                   </a:extLst>
                 </a:hlinkClick>
               </a:rPr>
-              <a:t>https://react.dev/learn/describing-the-ui</a:t>
+              <a:t>Fonte: React Docs — Describing the UI</a:t>
             </a:r>
             <a:endParaRPr lang="en-US" sz="740" dirty="0"/>
           </a:p>
@@ -12396,7 +12396,7 @@
                   </a:extLst>
                 </a:hlinkClick>
               </a:rPr>
-              <a:t>https://vite.dev/guide · https://react.dev/learn/build-a-react-app-from-scratch</a:t>
+              <a:t>Fontes: Vite Guide · React — Build from Scratch</a:t>
             </a:r>
             <a:endParaRPr lang="en-US" sz="740" dirty="0"/>
           </a:p>
@@ -13379,7 +13379,7 @@
                 <a:ea typeface="Consolas" pitchFamily="34" charset="-122"/>
                 <a:cs typeface="Consolas" pitchFamily="34" charset="-120"/>
               </a:rPr>
-              <a:t>  tasksReducer, initialTasks</a:t>
+              <a:t xml:space="preserve">  tasksReducer, initialTasks</a:t>
             </a:r>
             <a:endParaRPr lang="en-US" sz="1230" dirty="0"/>
           </a:p>
@@ -13436,7 +13436,7 @@
                 <a:ea typeface="Consolas" pitchFamily="34" charset="-122"/>
                 <a:cs typeface="Consolas" pitchFamily="34" charset="-120"/>
               </a:rPr>
-              <a:t>  localStorage.setItem("tasks", JSON.stringify(tasks));</a:t>
+              <a:t xml:space="preserve">  localStorage.setItem("tasks", JSON.stringify(tasks));</a:t>
             </a:r>
             <a:endParaRPr lang="en-US" sz="1230" dirty="0"/>
           </a:p>
@@ -13789,7 +13789,7 @@
                   </a:extLst>
                 </a:hlinkClick>
               </a:rPr>
-              <a:t>https://react.dev/reference/react/hooks · Código do ReactLab</a:t>
+              <a:t>Fontes: React Hooks · código do ReactLab</a:t>
             </a:r>
             <a:endParaRPr lang="en-US" sz="740" dirty="0"/>
           </a:p>

</xml_diff>

<commit_message>
docs: ajusta título do slide de instalação
</commit_message>
<xml_diff>
--- a/ENTREGAVEIS/Seminario_React_2ADS.pptx
+++ b/ENTREGAVEIS/Seminario_React_2ADS.pptx
@@ -26027,7 +26027,7 @@
         <p:spPr>
           <a:xfrm>
             <a:off x="582615" y="1337310"/>
-            <a:ext cx="5692200" cy="425100"/>
+            <a:ext cx="6126480" cy="425100"/>
           </a:xfrm>
           <a:prstGeom prst="rect">
             <a:avLst/>
@@ -26058,7 +26058,7 @@
               <a:buNone/>
             </a:pPr>
             <a:r>
-              <a:rPr b="1" i="0" lang="pt-BR" sz="3200" u="none" cap="none" strike="noStrike">
+              <a:rPr b="1" i="0" lang="pt-BR" sz="2900" u="none" cap="none" strike="noStrike">
                 <a:solidFill>
                   <a:srgbClr val="ECF4F5"/>
                 </a:solidFill>
@@ -26067,7 +26067,7 @@
                 <a:cs typeface="Quattrocento Sans"/>
                 <a:sym typeface="Quattrocento Sans"/>
               </a:rPr>
-              <a:t>Primeiro projeto com Vite</a:t>
+              <a:t>Criando um projeto React com Vite</a:t>
             </a:r>
             <a:endParaRPr b="0" i="0" sz="3200" u="none" cap="none" strike="noStrike">
               <a:solidFill>

</xml_diff>

<commit_message>
Atualiza apresentacao editada do seminario React
</commit_message>
<xml_diff>
--- a/ENTREGAVEIS/Seminario_React_2ADS.pptx
+++ b/ENTREGAVEIS/Seminario_React_2ADS.pptx
@@ -26026,8 +26026,8 @@
         </p:nvSpPr>
         <p:spPr>
           <a:xfrm>
-            <a:off x="582615" y="1337310"/>
-            <a:ext cx="6126480" cy="425100"/>
+            <a:off x="582625" y="1151250"/>
+            <a:ext cx="4230600" cy="425100"/>
           </a:xfrm>
           <a:prstGeom prst="rect">
             <a:avLst/>
@@ -26058,7 +26058,7 @@
               <a:buNone/>
             </a:pPr>
             <a:r>
-              <a:rPr b="1" i="0" lang="pt-BR" sz="2900" u="none" cap="none" strike="noStrike">
+              <a:rPr b="1" lang="pt-BR" sz="3200">
                 <a:solidFill>
                   <a:srgbClr val="ECF4F5"/>
                 </a:solidFill>
@@ -30133,6 +30133,285 @@
 </file>
 
 <file path=ppt/theme/theme1.xml><?xml version="1.0" encoding="utf-8"?>
+<a:theme xmlns:a="http://schemas.openxmlformats.org/drawingml/2006/main" xmlns:r="http://schemas.openxmlformats.org/officeDocument/2006/relationships">
+  <a:themeElements>
+    <a:clrScheme name="Default">
+      <a:dk1>
+        <a:srgbClr val="000000"/>
+      </a:dk1>
+      <a:lt1>
+        <a:srgbClr val="FFFFFF"/>
+      </a:lt1>
+      <a:dk2>
+        <a:srgbClr val="158158"/>
+      </a:dk2>
+      <a:lt2>
+        <a:srgbClr val="F3F3F3"/>
+      </a:lt2>
+      <a:accent1>
+        <a:srgbClr val="058DC7"/>
+      </a:accent1>
+      <a:accent2>
+        <a:srgbClr val="50B432"/>
+      </a:accent2>
+      <a:accent3>
+        <a:srgbClr val="ED561B"/>
+      </a:accent3>
+      <a:accent4>
+        <a:srgbClr val="EDEF00"/>
+      </a:accent4>
+      <a:accent5>
+        <a:srgbClr val="24CBE5"/>
+      </a:accent5>
+      <a:accent6>
+        <a:srgbClr val="64E572"/>
+      </a:accent6>
+      <a:hlink>
+        <a:srgbClr val="2200CC"/>
+      </a:hlink>
+      <a:folHlink>
+        <a:srgbClr val="551A8B"/>
+      </a:folHlink>
+    </a:clrScheme>
+    <a:fontScheme name="Office">
+      <a:majorFont>
+        <a:latin typeface="Arial"/>
+        <a:ea typeface=""/>
+        <a:cs typeface=""/>
+        <a:font script="Jpan" typeface="ＭＳ Ｐゴシック"/>
+        <a:font script="Hang" typeface="맑은 고딕"/>
+        <a:font script="Hans" typeface="宋体"/>
+        <a:font script="Hant" typeface="新細明體"/>
+        <a:font script="Arab" typeface="Times New Roman"/>
+        <a:font script="Hebr" typeface="Times New Roman"/>
+        <a:font script="Thai" typeface="Angsana New"/>
+        <a:font script="Ethi" typeface="Nyala"/>
+        <a:font script="Beng" typeface="Vrinda"/>
+        <a:font script="Gujr" typeface="Shruti"/>
+        <a:font script="Khmr" typeface="MoolBoran"/>
+        <a:font script="Knda" typeface="Tunga"/>
+        <a:font script="Guru" typeface="Raavi"/>
+        <a:font script="Cans" typeface="Euphemia"/>
+        <a:font script="Cher" typeface="Plantagenet Cherokee"/>
+        <a:font script="Yiii" typeface="Microsoft Yi Baiti"/>
+        <a:font script="Tibt" typeface="Microsoft Himalaya"/>
+        <a:font script="Thaa" typeface="MV Boli"/>
+        <a:font script="Deva" typeface="Mangal"/>
+        <a:font script="Telu" typeface="Gautami"/>
+        <a:font script="Taml" typeface="Latha"/>
+        <a:font script="Syrc" typeface="Estrangelo Edessa"/>
+        <a:font script="Orya" typeface="Kalinga"/>
+        <a:font script="Mlym" typeface="Kartika"/>
+        <a:font script="Laoo" typeface="DokChampa"/>
+        <a:font script="Sinh" typeface="Iskoola Pota"/>
+        <a:font script="Mong" typeface="Mongolian Baiti"/>
+        <a:font script="Viet" typeface="Times New Roman"/>
+        <a:font script="Uigh" typeface="Microsoft Uighur"/>
+        <a:font script="Geor" typeface="Sylfaen"/>
+      </a:majorFont>
+      <a:minorFont>
+        <a:latin typeface="Arial"/>
+        <a:ea typeface=""/>
+        <a:cs typeface=""/>
+        <a:font script="Jpan" typeface="ＭＳ Ｐゴシック"/>
+        <a:font script="Hang" typeface="맑은 고딕"/>
+        <a:font script="Hans" typeface="宋体"/>
+        <a:font script="Hant" typeface="新細明體"/>
+        <a:font script="Arab" typeface="Arial"/>
+        <a:font script="Hebr" typeface="Arial"/>
+        <a:font script="Thai" typeface="Cordia New"/>
+        <a:font script="Ethi" typeface="Nyala"/>
+        <a:font script="Beng" typeface="Vrinda"/>
+        <a:font script="Gujr" typeface="Shruti"/>
+        <a:font script="Khmr" typeface="DaunPenh"/>
+        <a:font script="Knda" typeface="Tunga"/>
+        <a:font script="Guru" typeface="Raavi"/>
+        <a:font script="Cans" typeface="Euphemia"/>
+        <a:font script="Cher" typeface="Plantagenet Cherokee"/>
+        <a:font script="Yiii" typeface="Microsoft Yi Baiti"/>
+        <a:font script="Tibt" typeface="Microsoft Himalaya"/>
+        <a:font script="Thaa" typeface="MV Boli"/>
+        <a:font script="Deva" typeface="Mangal"/>
+        <a:font script="Telu" typeface="Gautami"/>
+        <a:font script="Taml" typeface="Latha"/>
+        <a:font script="Syrc" typeface="Estrangelo Edessa"/>
+        <a:font script="Orya" typeface="Kalinga"/>
+        <a:font script="Mlym" typeface="Kartika"/>
+        <a:font script="Laoo" typeface="DokChampa"/>
+        <a:font script="Sinh" typeface="Iskoola Pota"/>
+        <a:font script="Mong" typeface="Mongolian Baiti"/>
+        <a:font script="Viet" typeface="Arial"/>
+        <a:font script="Uigh" typeface="Microsoft Uighur"/>
+        <a:font script="Geor" typeface="Sylfaen"/>
+      </a:minorFont>
+    </a:fontScheme>
+    <a:fmtScheme name="Office">
+      <a:fillStyleLst>
+        <a:solidFill>
+          <a:schemeClr val="phClr"/>
+        </a:solidFill>
+        <a:gradFill rotWithShape="1">
+          <a:gsLst>
+            <a:gs pos="0">
+              <a:schemeClr val="phClr">
+                <a:tint val="50000"/>
+                <a:satMod val="300000"/>
+              </a:schemeClr>
+            </a:gs>
+            <a:gs pos="35000">
+              <a:schemeClr val="phClr">
+                <a:tint val="37000"/>
+                <a:satMod val="300000"/>
+              </a:schemeClr>
+            </a:gs>
+            <a:gs pos="100000">
+              <a:schemeClr val="phClr">
+                <a:tint val="15000"/>
+                <a:satMod val="350000"/>
+              </a:schemeClr>
+            </a:gs>
+          </a:gsLst>
+          <a:lin ang="16200000" scaled="1"/>
+        </a:gradFill>
+        <a:gradFill rotWithShape="1">
+          <a:gsLst>
+            <a:gs pos="0">
+              <a:schemeClr val="phClr">
+                <a:tint val="100000"/>
+                <a:shade val="100000"/>
+                <a:satMod val="130000"/>
+              </a:schemeClr>
+            </a:gs>
+            <a:gs pos="100000">
+              <a:schemeClr val="phClr">
+                <a:tint val="50000"/>
+                <a:shade val="100000"/>
+                <a:satMod val="350000"/>
+              </a:schemeClr>
+            </a:gs>
+          </a:gsLst>
+          <a:lin ang="16200000" scaled="0"/>
+        </a:gradFill>
+      </a:fillStyleLst>
+      <a:lnStyleLst>
+        <a:ln w="9525" cap="flat" cmpd="sng" algn="ctr">
+          <a:solidFill>
+            <a:schemeClr val="phClr">
+              <a:shade val="95000"/>
+              <a:satMod val="105000"/>
+            </a:schemeClr>
+          </a:solidFill>
+          <a:prstDash val="solid"/>
+        </a:ln>
+        <a:ln w="25400" cap="flat" cmpd="sng" algn="ctr">
+          <a:solidFill>
+            <a:schemeClr val="phClr"/>
+          </a:solidFill>
+          <a:prstDash val="solid"/>
+        </a:ln>
+        <a:ln w="38100" cap="flat" cmpd="sng" algn="ctr">
+          <a:solidFill>
+            <a:schemeClr val="phClr"/>
+          </a:solidFill>
+          <a:prstDash val="solid"/>
+        </a:ln>
+      </a:lnStyleLst>
+      <a:effectStyleLst>
+        <a:effectStyle>
+          <a:effectLst>
+            <a:outerShdw blurRad="40000" dist="20000" dir="5400000" rotWithShape="0">
+              <a:srgbClr val="000000">
+                <a:alpha val="38000"/>
+              </a:srgbClr>
+            </a:outerShdw>
+          </a:effectLst>
+        </a:effectStyle>
+        <a:effectStyle>
+          <a:effectLst>
+            <a:outerShdw blurRad="40000" dist="23000" dir="5400000" rotWithShape="0">
+              <a:srgbClr val="000000">
+                <a:alpha val="35000"/>
+              </a:srgbClr>
+            </a:outerShdw>
+          </a:effectLst>
+        </a:effectStyle>
+        <a:effectStyle>
+          <a:effectLst>
+            <a:outerShdw blurRad="40000" dist="23000" dir="5400000" rotWithShape="0">
+              <a:srgbClr val="000000">
+                <a:alpha val="35000"/>
+              </a:srgbClr>
+            </a:outerShdw>
+          </a:effectLst>
+          <a:scene3d>
+            <a:camera prst="orthographicFront">
+              <a:rot lat="0" lon="0" rev="0"/>
+            </a:camera>
+            <a:lightRig rig="threePt" dir="t">
+              <a:rot lat="0" lon="0" rev="1200000"/>
+            </a:lightRig>
+          </a:scene3d>
+          <a:sp3d>
+            <a:bevelT w="63500" h="25400"/>
+          </a:sp3d>
+        </a:effectStyle>
+      </a:effectStyleLst>
+      <a:bgFillStyleLst>
+        <a:solidFill>
+          <a:schemeClr val="phClr"/>
+        </a:solidFill>
+        <a:gradFill rotWithShape="1">
+          <a:gsLst>
+            <a:gs pos="0">
+              <a:schemeClr val="phClr">
+                <a:tint val="40000"/>
+                <a:satMod val="350000"/>
+              </a:schemeClr>
+            </a:gs>
+            <a:gs pos="40000">
+              <a:schemeClr val="phClr">
+                <a:tint val="45000"/>
+                <a:shade val="99000"/>
+                <a:satMod val="350000"/>
+              </a:schemeClr>
+            </a:gs>
+            <a:gs pos="100000">
+              <a:schemeClr val="phClr">
+                <a:shade val="20000"/>
+                <a:satMod val="255000"/>
+              </a:schemeClr>
+            </a:gs>
+          </a:gsLst>
+          <a:path path="circle">
+            <a:fillToRect l="50000" t="-80000" r="50000" b="180000"/>
+          </a:path>
+        </a:gradFill>
+        <a:gradFill rotWithShape="1">
+          <a:gsLst>
+            <a:gs pos="0">
+              <a:schemeClr val="phClr">
+                <a:tint val="80000"/>
+                <a:satMod val="300000"/>
+              </a:schemeClr>
+            </a:gs>
+            <a:gs pos="100000">
+              <a:schemeClr val="phClr">
+                <a:shade val="30000"/>
+                <a:satMod val="200000"/>
+              </a:schemeClr>
+            </a:gs>
+          </a:gsLst>
+          <a:path path="circle">
+            <a:fillToRect l="50000" t="50000" r="50000" b="50000"/>
+          </a:path>
+        </a:gradFill>
+      </a:bgFillStyleLst>
+    </a:fmtScheme>
+  </a:themeElements>
+</a:theme>
+</file>
+
+<file path=ppt/theme/theme2.xml><?xml version="1.0" encoding="utf-8"?>
 <a:theme xmlns:a="http://schemas.openxmlformats.org/drawingml/2006/main" xmlns:r="http://schemas.openxmlformats.org/officeDocument/2006/relationships" name="Office Theme">
   <a:themeElements>
     <a:clrScheme name="Office">
@@ -30411,7 +30690,7 @@
 </a:theme>
 </file>
 
-<file path=ppt/theme/theme2.xml><?xml version="1.0" encoding="utf-8"?>
+<file path=ppt/theme/theme3.xml><?xml version="1.0" encoding="utf-8"?>
 <a:theme xmlns:a="http://schemas.openxmlformats.org/drawingml/2006/main" xmlns:r="http://schemas.openxmlformats.org/officeDocument/2006/relationships" name="Simple Light">
   <a:themeElements>
     <a:clrScheme name="Simple Light">
@@ -30688,283 +30967,4 @@
     </a:fmtScheme>
   </a:themeElements>
 </a:theme>
-</file>
-
-<file path=ppt/theme/theme3.xml><?xml version="1.0" encoding="utf-8"?>
-<a:theme xmlns:a="http://schemas.openxmlformats.org/drawingml/2006/main" xmlns:r="http://schemas.openxmlformats.org/officeDocument/2006/relationships">
-  <a:themeElements>
-    <a:clrScheme name="Default">
-      <a:dk1>
-        <a:srgbClr val="000000"/>
-      </a:dk1>
-      <a:lt1>
-        <a:srgbClr val="FFFFFF"/>
-      </a:lt1>
-      <a:dk2>
-        <a:srgbClr val="158158"/>
-      </a:dk2>
-      <a:lt2>
-        <a:srgbClr val="F3F3F3"/>
-      </a:lt2>
-      <a:accent1>
-        <a:srgbClr val="058DC7"/>
-      </a:accent1>
-      <a:accent2>
-        <a:srgbClr val="50B432"/>
-      </a:accent2>
-      <a:accent3>
-        <a:srgbClr val="ED561B"/>
-      </a:accent3>
-      <a:accent4>
-        <a:srgbClr val="EDEF00"/>
-      </a:accent4>
-      <a:accent5>
-        <a:srgbClr val="24CBE5"/>
-      </a:accent5>
-      <a:accent6>
-        <a:srgbClr val="64E572"/>
-      </a:accent6>
-      <a:hlink>
-        <a:srgbClr val="2200CC"/>
-      </a:hlink>
-      <a:folHlink>
-        <a:srgbClr val="551A8B"/>
-      </a:folHlink>
-    </a:clrScheme>
-    <a:fontScheme name="Office">
-      <a:majorFont>
-        <a:latin typeface="Arial"/>
-        <a:ea typeface=""/>
-        <a:cs typeface=""/>
-        <a:font script="Jpan" typeface="ＭＳ Ｐゴシック"/>
-        <a:font script="Hang" typeface="맑은 고딕"/>
-        <a:font script="Hans" typeface="宋体"/>
-        <a:font script="Hant" typeface="新細明體"/>
-        <a:font script="Arab" typeface="Times New Roman"/>
-        <a:font script="Hebr" typeface="Times New Roman"/>
-        <a:font script="Thai" typeface="Angsana New"/>
-        <a:font script="Ethi" typeface="Nyala"/>
-        <a:font script="Beng" typeface="Vrinda"/>
-        <a:font script="Gujr" typeface="Shruti"/>
-        <a:font script="Khmr" typeface="MoolBoran"/>
-        <a:font script="Knda" typeface="Tunga"/>
-        <a:font script="Guru" typeface="Raavi"/>
-        <a:font script="Cans" typeface="Euphemia"/>
-        <a:font script="Cher" typeface="Plantagenet Cherokee"/>
-        <a:font script="Yiii" typeface="Microsoft Yi Baiti"/>
-        <a:font script="Tibt" typeface="Microsoft Himalaya"/>
-        <a:font script="Thaa" typeface="MV Boli"/>
-        <a:font script="Deva" typeface="Mangal"/>
-        <a:font script="Telu" typeface="Gautami"/>
-        <a:font script="Taml" typeface="Latha"/>
-        <a:font script="Syrc" typeface="Estrangelo Edessa"/>
-        <a:font script="Orya" typeface="Kalinga"/>
-        <a:font script="Mlym" typeface="Kartika"/>
-        <a:font script="Laoo" typeface="DokChampa"/>
-        <a:font script="Sinh" typeface="Iskoola Pota"/>
-        <a:font script="Mong" typeface="Mongolian Baiti"/>
-        <a:font script="Viet" typeface="Times New Roman"/>
-        <a:font script="Uigh" typeface="Microsoft Uighur"/>
-        <a:font script="Geor" typeface="Sylfaen"/>
-      </a:majorFont>
-      <a:minorFont>
-        <a:latin typeface="Arial"/>
-        <a:ea typeface=""/>
-        <a:cs typeface=""/>
-        <a:font script="Jpan" typeface="ＭＳ Ｐゴシック"/>
-        <a:font script="Hang" typeface="맑은 고딕"/>
-        <a:font script="Hans" typeface="宋体"/>
-        <a:font script="Hant" typeface="新細明體"/>
-        <a:font script="Arab" typeface="Arial"/>
-        <a:font script="Hebr" typeface="Arial"/>
-        <a:font script="Thai" typeface="Cordia New"/>
-        <a:font script="Ethi" typeface="Nyala"/>
-        <a:font script="Beng" typeface="Vrinda"/>
-        <a:font script="Gujr" typeface="Shruti"/>
-        <a:font script="Khmr" typeface="DaunPenh"/>
-        <a:font script="Knda" typeface="Tunga"/>
-        <a:font script="Guru" typeface="Raavi"/>
-        <a:font script="Cans" typeface="Euphemia"/>
-        <a:font script="Cher" typeface="Plantagenet Cherokee"/>
-        <a:font script="Yiii" typeface="Microsoft Yi Baiti"/>
-        <a:font script="Tibt" typeface="Microsoft Himalaya"/>
-        <a:font script="Thaa" typeface="MV Boli"/>
-        <a:font script="Deva" typeface="Mangal"/>
-        <a:font script="Telu" typeface="Gautami"/>
-        <a:font script="Taml" typeface="Latha"/>
-        <a:font script="Syrc" typeface="Estrangelo Edessa"/>
-        <a:font script="Orya" typeface="Kalinga"/>
-        <a:font script="Mlym" typeface="Kartika"/>
-        <a:font script="Laoo" typeface="DokChampa"/>
-        <a:font script="Sinh" typeface="Iskoola Pota"/>
-        <a:font script="Mong" typeface="Mongolian Baiti"/>
-        <a:font script="Viet" typeface="Arial"/>
-        <a:font script="Uigh" typeface="Microsoft Uighur"/>
-        <a:font script="Geor" typeface="Sylfaen"/>
-      </a:minorFont>
-    </a:fontScheme>
-    <a:fmtScheme name="Office">
-      <a:fillStyleLst>
-        <a:solidFill>
-          <a:schemeClr val="phClr"/>
-        </a:solidFill>
-        <a:gradFill rotWithShape="1">
-          <a:gsLst>
-            <a:gs pos="0">
-              <a:schemeClr val="phClr">
-                <a:tint val="50000"/>
-                <a:satMod val="300000"/>
-              </a:schemeClr>
-            </a:gs>
-            <a:gs pos="35000">
-              <a:schemeClr val="phClr">
-                <a:tint val="37000"/>
-                <a:satMod val="300000"/>
-              </a:schemeClr>
-            </a:gs>
-            <a:gs pos="100000">
-              <a:schemeClr val="phClr">
-                <a:tint val="15000"/>
-                <a:satMod val="350000"/>
-              </a:schemeClr>
-            </a:gs>
-          </a:gsLst>
-          <a:lin ang="16200000" scaled="1"/>
-        </a:gradFill>
-        <a:gradFill rotWithShape="1">
-          <a:gsLst>
-            <a:gs pos="0">
-              <a:schemeClr val="phClr">
-                <a:tint val="100000"/>
-                <a:shade val="100000"/>
-                <a:satMod val="130000"/>
-              </a:schemeClr>
-            </a:gs>
-            <a:gs pos="100000">
-              <a:schemeClr val="phClr">
-                <a:tint val="50000"/>
-                <a:shade val="100000"/>
-                <a:satMod val="350000"/>
-              </a:schemeClr>
-            </a:gs>
-          </a:gsLst>
-          <a:lin ang="16200000" scaled="0"/>
-        </a:gradFill>
-      </a:fillStyleLst>
-      <a:lnStyleLst>
-        <a:ln w="9525" cap="flat" cmpd="sng" algn="ctr">
-          <a:solidFill>
-            <a:schemeClr val="phClr">
-              <a:shade val="95000"/>
-              <a:satMod val="105000"/>
-            </a:schemeClr>
-          </a:solidFill>
-          <a:prstDash val="solid"/>
-        </a:ln>
-        <a:ln w="25400" cap="flat" cmpd="sng" algn="ctr">
-          <a:solidFill>
-            <a:schemeClr val="phClr"/>
-          </a:solidFill>
-          <a:prstDash val="solid"/>
-        </a:ln>
-        <a:ln w="38100" cap="flat" cmpd="sng" algn="ctr">
-          <a:solidFill>
-            <a:schemeClr val="phClr"/>
-          </a:solidFill>
-          <a:prstDash val="solid"/>
-        </a:ln>
-      </a:lnStyleLst>
-      <a:effectStyleLst>
-        <a:effectStyle>
-          <a:effectLst>
-            <a:outerShdw blurRad="40000" dist="20000" dir="5400000" rotWithShape="0">
-              <a:srgbClr val="000000">
-                <a:alpha val="38000"/>
-              </a:srgbClr>
-            </a:outerShdw>
-          </a:effectLst>
-        </a:effectStyle>
-        <a:effectStyle>
-          <a:effectLst>
-            <a:outerShdw blurRad="40000" dist="23000" dir="5400000" rotWithShape="0">
-              <a:srgbClr val="000000">
-                <a:alpha val="35000"/>
-              </a:srgbClr>
-            </a:outerShdw>
-          </a:effectLst>
-        </a:effectStyle>
-        <a:effectStyle>
-          <a:effectLst>
-            <a:outerShdw blurRad="40000" dist="23000" dir="5400000" rotWithShape="0">
-              <a:srgbClr val="000000">
-                <a:alpha val="35000"/>
-              </a:srgbClr>
-            </a:outerShdw>
-          </a:effectLst>
-          <a:scene3d>
-            <a:camera prst="orthographicFront">
-              <a:rot lat="0" lon="0" rev="0"/>
-            </a:camera>
-            <a:lightRig rig="threePt" dir="t">
-              <a:rot lat="0" lon="0" rev="1200000"/>
-            </a:lightRig>
-          </a:scene3d>
-          <a:sp3d>
-            <a:bevelT w="63500" h="25400"/>
-          </a:sp3d>
-        </a:effectStyle>
-      </a:effectStyleLst>
-      <a:bgFillStyleLst>
-        <a:solidFill>
-          <a:schemeClr val="phClr"/>
-        </a:solidFill>
-        <a:gradFill rotWithShape="1">
-          <a:gsLst>
-            <a:gs pos="0">
-              <a:schemeClr val="phClr">
-                <a:tint val="40000"/>
-                <a:satMod val="350000"/>
-              </a:schemeClr>
-            </a:gs>
-            <a:gs pos="40000">
-              <a:schemeClr val="phClr">
-                <a:tint val="45000"/>
-                <a:shade val="99000"/>
-                <a:satMod val="350000"/>
-              </a:schemeClr>
-            </a:gs>
-            <a:gs pos="100000">
-              <a:schemeClr val="phClr">
-                <a:shade val="20000"/>
-                <a:satMod val="255000"/>
-              </a:schemeClr>
-            </a:gs>
-          </a:gsLst>
-          <a:path path="circle">
-            <a:fillToRect l="50000" t="-80000" r="50000" b="180000"/>
-          </a:path>
-        </a:gradFill>
-        <a:gradFill rotWithShape="1">
-          <a:gsLst>
-            <a:gs pos="0">
-              <a:schemeClr val="phClr">
-                <a:tint val="80000"/>
-                <a:satMod val="300000"/>
-              </a:schemeClr>
-            </a:gs>
-            <a:gs pos="100000">
-              <a:schemeClr val="phClr">
-                <a:shade val="30000"/>
-                <a:satMod val="200000"/>
-              </a:schemeClr>
-            </a:gs>
-          </a:gsLst>
-          <a:path path="circle">
-            <a:fillToRect l="50000" t="50000" r="50000" b="50000"/>
-          </a:path>
-        </a:gradFill>
-      </a:bgFillStyleLst>
-    </a:fmtScheme>
-  </a:themeElements>
-</a:theme>
 </file>
</xml_diff>